<commit_message>
Mention the live dashboard in the report and slides
Adds the deployed dashboard URL to the report cover and repository section and to the closing slide, and regenerates the report data (25 commits at generation), Word and PDF report and the deck.
</commit_message>
<xml_diff>
--- a/docs/presentation/AML_Traffic_Flow_Forecasting.pptx
+++ b/docs/presentation/AML_Traffic_Flow_Forecasting.pptx
@@ -117,33 +117,33 @@
   <p:extLst>
     <p:ext uri="{521415D9-36F7-43E2-AB2F-B90AF26B5E84}">
       <p14:sectionLst xmlns:p14="http://schemas.microsoft.com/office/powerpoint/2010/main">
-        <p14:section name="Overview" id="{a3518deb-2b64-e858-9d49-43c3e8d5f467}">
+        <p14:section name="Overview" id="{51ae96aa-3824-9b99-d8a1-3881033583d9}">
           <p14:sldIdLst>
             <p14:sldId id="256"/>
             <p14:sldId id="257"/>
           </p14:sldIdLst>
         </p14:section>
-        <p14:section name="Method" id="{2d2205fe-3f44-c032-18d0-4b0ec20a2b85}">
+        <p14:section name="Method" id="{402d6db1-e3c2-177f-3df0-844f27b2a3ed}">
           <p14:sldIdLst>
             <p14:sldId id="258"/>
             <p14:sldId id="259"/>
             <p14:sldId id="260"/>
           </p14:sldIdLst>
         </p14:section>
-        <p14:section name="Results" id="{1522b73d-9287-bb06-9de8-a6637ae2c200}">
+        <p14:section name="Results" id="{ee18a7a2-a9ee-9722-4921-b6d0bc81d572}">
           <p14:sldIdLst>
             <p14:sldId id="261"/>
             <p14:sldId id="262"/>
             <p14:sldId id="263"/>
           </p14:sldIdLst>
         </p14:section>
-        <p14:section name="The gap" id="{ab032d54-c9d8-5688-86e3-26508d33f312}">
+        <p14:section name="The gap" id="{43a3fd91-3f50-2a8a-3871-470d271a1d3d}">
           <p14:sldIdLst>
             <p14:sldId id="264"/>
             <p14:sldId id="265"/>
           </p14:sldIdLst>
         </p14:section>
-        <p14:section name="Wrap-up" id="{ac4e1b3d-0953-0f2a-d95c-640e687bf66e}">
+        <p14:section name="Wrap-up" id="{92003bd1-bd1b-981e-fa76-3f7060fca534}">
           <p14:sldIdLst>
             <p14:sldId id="266"/>
           </p14:sldIdLst>
@@ -6941,7 +6941,25 @@
                   <a:schemeClr val="bg1"/>
                 </a:solidFill>
               </a:rPr>
-              <a:t>Interactive Streamlit dashboard (Sumit)</a:t>
+              <a:t>Live Streamlit dashboard (Sumit)</a:t>
+            </a:r>
+            <a:endParaRPr lang="en-US" sz="1300" dirty="0"/>
+          </a:p>
+          <a:p>
+            <a:pPr marL="342900" indent="-342900">
+              <a:spcAft>
+                <a:spcPts val="400"/>
+              </a:spcAft>
+              <a:buSzPct val="100000"/>
+              <a:buChar char="•"/>
+            </a:pPr>
+            <a:r>
+              <a:rPr lang="en-US" sz="1200" dirty="0">
+                <a:solidFill>
+                  <a:schemeClr val="bg1"/>
+                </a:solidFill>
+              </a:rPr>
+              <a:t>trafficflowamldl.streamlit.app</a:t>
             </a:r>
             <a:endParaRPr lang="en-US" sz="1300" dirty="0"/>
           </a:p>

</xml_diff>

<commit_message>
Update the slides to match the report
Rebuilds the deck from full-precision results so every score agrees with the report, and points the closing slide to the LaTeX report and the live dashboard.
</commit_message>
<xml_diff>
--- a/docs/presentation/AML_Traffic_Flow_Forecasting.pptx
+++ b/docs/presentation/AML_Traffic_Flow_Forecasting.pptx
@@ -117,33 +117,33 @@
   <p:extLst>
     <p:ext uri="{521415D9-36F7-43E2-AB2F-B90AF26B5E84}">
       <p14:sectionLst xmlns:p14="http://schemas.microsoft.com/office/powerpoint/2010/main">
-        <p14:section name="Overview" id="{51ae96aa-3824-9b99-d8a1-3881033583d9}">
+        <p14:section name="Overview" id="{195d4618-0764-5622-86f0-0725b9a9154e}">
           <p14:sldIdLst>
             <p14:sldId id="256"/>
             <p14:sldId id="257"/>
           </p14:sldIdLst>
         </p14:section>
-        <p14:section name="Method" id="{402d6db1-e3c2-177f-3df0-844f27b2a3ed}">
+        <p14:section name="Method" id="{a7b69f56-3613-9171-e03a-5ca799904926}">
           <p14:sldIdLst>
             <p14:sldId id="258"/>
             <p14:sldId id="259"/>
             <p14:sldId id="260"/>
           </p14:sldIdLst>
         </p14:section>
-        <p14:section name="Results" id="{ee18a7a2-a9ee-9722-4921-b6d0bc81d572}">
+        <p14:section name="Results" id="{77ca55ad-5daf-407a-91d8-a21933541ef3}">
           <p14:sldIdLst>
             <p14:sldId id="261"/>
             <p14:sldId id="262"/>
             <p14:sldId id="263"/>
           </p14:sldIdLst>
         </p14:section>
-        <p14:section name="The gap" id="{43a3fd91-3f50-2a8a-3871-470d271a1d3d}">
+        <p14:section name="The gap" id="{3b3187ef-634f-6911-e3b8-c367058beb17}">
           <p14:sldIdLst>
             <p14:sldId id="264"/>
             <p14:sldId id="265"/>
           </p14:sldIdLst>
         </p14:section>
-        <p14:section name="Wrap-up" id="{92003bd1-bd1b-981e-fa76-3f7060fca534}">
+        <p14:section name="Wrap-up" id="{a3afbad0-0084-e2da-1d57-75b152aff294}">
           <p14:sldIdLst>
             <p14:sldId id="266"/>
           </p14:sldIdLst>
@@ -6923,7 +6923,7 @@
                   <a:schemeClr val="bg1"/>
                 </a:solidFill>
               </a:rPr>
-              <a:t>Reports for Phases 1 to 4, 39 automated tests</a:t>
+              <a:t>LaTeX project report, 40 automated tests</a:t>
             </a:r>
             <a:endParaRPr lang="en-US" sz="1300" dirty="0"/>
           </a:p>
@@ -15448,7 +15448,7 @@
                             <a:srgbClr val="0B1730"/>
                           </a:solidFill>
                         </a:rPr>
-                        <a:t>5.62</a:t>
+                        <a:t>5.61</a:t>
                       </a:r>
                       <a:endParaRPr lang="en-US" sz="1300" dirty="0"/>
                     </a:p>
@@ -16182,7 +16182,7 @@
                             <a:srgbClr val="0B1730"/>
                           </a:solidFill>
                         </a:rPr>
-                        <a:t>7.20</a:t>
+                        <a:t>7.19</a:t>
                       </a:r>
                       <a:endParaRPr lang="en-US" sz="1300" dirty="0"/>
                     </a:p>
@@ -16916,7 +16916,7 @@
                             <a:srgbClr val="0B7A52"/>
                           </a:solidFill>
                         </a:rPr>
-                        <a:t>7.28</a:t>
+                        <a:t>7.27</a:t>
                       </a:r>
                       <a:endParaRPr lang="en-US" sz="1300" dirty="0"/>
                     </a:p>

</xml_diff>

<commit_message>
Slides: set document properties
</commit_message>
<xml_diff>
--- a/docs/presentation/AML_Traffic_Flow_Forecasting.pptx
+++ b/docs/presentation/AML_Traffic_Flow_Forecasting.pptx
@@ -119,34 +119,34 @@
   <p:extLst>
     <p:ext uri="{521415D9-36F7-43E2-AB2F-B90AF26B5E84}">
       <p14:sectionLst xmlns:p14="http://schemas.microsoft.com/office/powerpoint/2010/main">
-        <p14:section name="Overview" id="{82155768-d959-20cf-fad9-3c7fff23891e}">
+        <p14:section name="Overview" id="{8c069451-d5d6-cbf5-46a0-1f50115a84b5}">
           <p14:sldIdLst>
             <p14:sldId id="256"/>
             <p14:sldId id="257"/>
             <p14:sldId id="258"/>
           </p14:sldIdLst>
         </p14:section>
-        <p14:section name="Method" id="{8825e7f3-9272-5af2-b62b-ecdae53fb614}">
+        <p14:section name="Method" id="{75c0e378-9eb1-4a71-3d56-74f2d675ca90}">
           <p14:sldIdLst>
             <p14:sldId id="259"/>
             <p14:sldId id="260"/>
             <p14:sldId id="261"/>
           </p14:sldIdLst>
         </p14:section>
-        <p14:section name="Results" id="{5e156301-5005-47bd-69c6-4e750d3d184c}">
+        <p14:section name="Results" id="{424004b2-d36f-c0e8-9064-75ae2f27eb0a}">
           <p14:sldIdLst>
             <p14:sldId id="262"/>
             <p14:sldId id="263"/>
             <p14:sldId id="264"/>
           </p14:sldIdLst>
         </p14:section>
-        <p14:section name="The gap" id="{51f5cc71-5a28-f5b6-d18a-f01d862a39ef}">
+        <p14:section name="The gap" id="{075e1788-49d8-ebd1-9220-11397a4fcac2}">
           <p14:sldIdLst>
             <p14:sldId id="265"/>
             <p14:sldId id="266"/>
           </p14:sldIdLst>
         </p14:section>
-        <p14:section name="Wrap-up" id="{6fc6f8e8-6a15-c5ef-43a7-b9109bdd0ffe}">
+        <p14:section name="Wrap-up" id="{c414c0ab-b749-8349-24fd-241f3a36a251}">
           <p14:sldIdLst>
             <p14:sldId id="267"/>
             <p14:sldId id="268"/>

</xml_diff>